<commit_message>
Update Video Presentation of Functional and Technical Specifications RCoon.pptx
</commit_message>
<xml_diff>
--- a/SWE-540/Topic 8/Video Presentation of Functional and Technical Specifications RCoon.pptx
+++ b/SWE-540/Topic 8/Video Presentation of Functional and Technical Specifications RCoon.pptx
@@ -122,6 +122,11 @@
       </a:defRPr>
     </a:lvl9pPr>
   </p:defaultTextStyle>
+  <p:extLst>
+    <p:ext uri="{EFAFB233-063F-42B5-8137-9DF3F51BA10A}">
+      <p15:sldGuideLst xmlns:p15="http://schemas.microsoft.com/office/powerpoint/2012/main"/>
+    </p:ext>
+  </p:extLst>
 </p:presentation>
 </file>
 
@@ -341,9 +346,12 @@
           <a:lstStyle/>
           <a:p>
             <a:r>
-              <a:rPr dirty="0"/>
-              <a:t>Hello everyone, and welcome to my presentation on the Byte Bazaar project. In this presentation, I will walk through all major aspects of the project, including the economic analysis, team leadership considerations, planning and control phase of the SDLC, functional and technical specifications, and the analysis, design, and management of the system development process. I will also explain the SDLC methods, testing models, and development practices that are most appropriate for this project.</a:t>
-            </a:r>
+              <a:rPr lang="en-US" sz="1200" b="0" i="0" kern="1200" dirty="0">
+                <a:effectLst/>
+              </a:rPr>
+              <a:t>Welcome to my presentation on the Byte Bazaar project. Over the next 15 minutes, I will provide a detailed overview of the project, starting from the economic analysis and team leadership aspects, moving through the design of functional and technical specifications, and concluding with how we apply the Software Development Life Cycle to ensure a successful software development process. This presentation aims to give a holistic view of how Byte Bazaar is planned, developed, and managed.</a:t>
+            </a:r>
+            <a:endParaRPr dirty="0"/>
           </a:p>
         </p:txBody>
       </p:sp>
@@ -419,9 +427,12 @@
           <a:lstStyle/>
           <a:p>
             <a:r>
-              <a:rPr dirty="0"/>
-              <a:t>System analysis focused on understanding the business problem and translating it into system requirements. For Byte Bazaar, this included reviewing how users interact with the system, what data needs to be processed, and what outputs are required. The analysis also identified constraints such as time, budget, and technology limitations. This stage ensured that the project requirements aligned with the desired outcomes of the business and users.</a:t>
-            </a:r>
+              <a:rPr lang="en-US" sz="1200" b="0" i="0" kern="1200" dirty="0">
+                <a:effectLst/>
+              </a:rPr>
+              <a:t>System analysis involved gathering detailed requirements from business stakeholders and users. We identified all inputs, such as user data and product information, and outputs like order confirmations and sales reports. Mapping workflows and data flows helped clarify system operations. Constraints such as budget limits, project timeline, and technology choices were considered. Risks including potential security threats and integration challenges were evaluated to prepare mitigation strategies.</a:t>
+            </a:r>
+            <a:endParaRPr dirty="0"/>
           </a:p>
         </p:txBody>
       </p:sp>
@@ -497,9 +508,12 @@
           <a:lstStyle/>
           <a:p>
             <a:r>
-              <a:rPr dirty="0"/>
-              <a:t>The design phase translated requirements into a practical system plan. This included designing the user interface, organizing workflows, creating the database structure, and mapping how information moves through the system. For Byte Bazaar, design decisions focused on usability, efficient navigation, secure transactions, and scalable architecture. The design phase provides the framework developers will use during implementation.</a:t>
-            </a:r>
+              <a:rPr lang="en-US" sz="1200" b="0" i="0" kern="1200" dirty="0">
+                <a:effectLst/>
+              </a:rPr>
+              <a:t>In the design phase, we created modular system components to facilitate maintainability and scalability. User interface wireframes were developed with a focus on intuitive navigation and accessibility. Data flow diagrams detailed backend processes such as order processing and inventory updates. Integration points with payment gateways and external services were planned carefully, including error handling mechanisms. The design also ensures responsiveness, so the platform works well on desktops, tablets, and smartphones.</a:t>
+            </a:r>
+            <a:endParaRPr dirty="0"/>
           </a:p>
         </p:txBody>
       </p:sp>
@@ -575,9 +589,12 @@
           <a:lstStyle/>
           <a:p>
             <a:r>
-              <a:rPr dirty="0"/>
-              <a:t>Managing the development of Byte Bazaar involves coordinating activities across all phases of the SDLC. This includes tracking milestones, ensuring tasks are completed on schedule, and balancing project constraints such as cost, quality, and time. Communication with stakeholders remains essential throughout development to ensure the project continues to meet expectations and adapt to changes when necessary.</a:t>
-            </a:r>
+              <a:rPr lang="en-US" sz="1200" b="0" i="0" kern="1200" dirty="0">
+                <a:effectLst/>
+              </a:rPr>
+              <a:t>Managing development required coordinating tasks across all SDLC phases using tools like Jira or Trello. Progress was tracked against milestones and deliverables to ensure timely completion. Balancing cost, quality, and schedule was a constant focus to deliver value without compromising standards. Effective communication channels between developers, testers, and stakeholders helped resolve issues quickly and keep everyone aligned.</a:t>
+            </a:r>
+            <a:endParaRPr dirty="0"/>
           </a:p>
         </p:txBody>
       </p:sp>
@@ -653,9 +670,12 @@
           <a:lstStyle/>
           <a:p>
             <a:r>
-              <a:rPr dirty="0"/>
-              <a:t>For Byte Bazaar, Agile is an appropriate SDLC approach because it supports incremental development, regular feedback, and continuous improvement. The project can be divided into smaller parts, allowing features such as login, product browsing, and checkout to be developed and reviewed in stages. This helps reduce risk, improve adaptability, and ensure that the final system stays aligned with project requirements.</a:t>
-            </a:r>
+              <a:rPr lang="en-US" sz="1200" b="0" i="0" kern="1200" dirty="0">
+                <a:effectLst/>
+              </a:rPr>
+              <a:t>We adopted Agile methodology to allow flexibility and iterative progress. Features were delivered incrementally in sprints, enabling early testing and feedback. User stories were used to validate requirements continuously, ensuring the product met user needs. Comprehensive documentation and version control practices ensured traceability and facilitated collaboration.</a:t>
+            </a:r>
+            <a:endParaRPr dirty="0"/>
           </a:p>
         </p:txBody>
       </p:sp>
@@ -731,9 +751,12 @@
           <a:lstStyle/>
           <a:p>
             <a:r>
-              <a:rPr dirty="0"/>
-              <a:t>Testing is critical to software quality and reliability. Unit testing ensures that individual functions work correctly. Integration testing confirms that system components interact properly. System testing evaluates the entire application, while user acceptance testing verifies that the system meets business and user requirements. Because Byte Bazaar is an e-commerce platform, security testing and performance testing are especially important to protect data and ensure smooth operation.</a:t>
-            </a:r>
+              <a:rPr lang="en-US" sz="1200" b="0" i="0" kern="1200" dirty="0">
+                <a:effectLst/>
+              </a:rPr>
+              <a:t>Testing was conducted at multiple levels: unit testing verified individual components, integration testing ensured modules worked together, and system testing validated end-to-end functionality. User acceptance testing confirmed the system met business requirements. Security testing protected against vulnerabilities, and performance testing ensured the system could handle expected loads without degradation.</a:t>
+            </a:r>
+            <a:endParaRPr dirty="0"/>
           </a:p>
         </p:txBody>
       </p:sp>
@@ -809,9 +832,12 @@
           <a:lstStyle/>
           <a:p>
             <a:r>
-              <a:rPr dirty="0"/>
-              <a:t>In conclusion, Byte Bazaar is a project that benefits greatly from a structured SDLC approach. The planning and control phase establishes direction and accountability, while the functional and technical specifications provide a clear roadmap for development. System analysis and design ensure that the platform meets user and business needs within realistic constraints. Finally, Agile development practices and strong testing models help produce a secure, reliable, and effective e-commerce solution. Thank you</a:t>
-            </a:r>
+              <a:rPr lang="en-US" sz="1200" b="0" i="0" kern="1200" dirty="0">
+                <a:effectLst/>
+              </a:rPr>
+              <a:t>In conclusion, Byte Bazaar’s success is built on a structured SDLC approach supported by clear functional and technical specifications. The planning and control phases help mitigate risks and keep the project aligned with goals. Agile development and rigorous testing practices ensure high quality and adaptability. Together, these efforts deliver a system that meets both business objectives and user expectations effectively. Thank you for your attention.</a:t>
+            </a:r>
+            <a:endParaRPr dirty="0"/>
           </a:p>
         </p:txBody>
       </p:sp>
@@ -962,9 +988,12 @@
           <a:lstStyle/>
           <a:p>
             <a:r>
-              <a:rPr dirty="0"/>
-              <a:t>Byte Bazaar is a computing-based e-commerce system designed to provide users with an efficient and secure online marketplace experience. The system supports essential online shopping features such as product browsing, account management, cart functionality, and secure checkout. The main project goal is to create a system that is user-friendly, scalable, reliable, and aligned with both customer expectations and business objectives.</a:t>
-            </a:r>
+              <a:rPr lang="en-US" sz="1200" b="0" i="0" kern="1200" dirty="0">
+                <a:effectLst/>
+              </a:rPr>
+              <a:t>Byte Bazaar is envisioned as a comprehensive e-commerce platform that enables users to browse, select, and purchase products online with ease. The system is designed with a strong focus on usability to ensure a smooth user experience, security to protect sensitive data and transactions, and scalability to support growth in users and product listings. It serves both end customers and administrators who manage product inventories and orders.</a:t>
+            </a:r>
+            <a:endParaRPr dirty="0"/>
           </a:p>
         </p:txBody>
       </p:sp>
@@ -1039,10 +1068,32 @@
           <a:bodyPr/>
           <a:lstStyle/>
           <a:p>
-            <a:r>
-              <a:rPr dirty="0"/>
-              <a:t>The primary goals of Byte Bazaar are to improve the online shopping experience, ensure secure transactions, and provide the business with effective tools for managing products and orders. The system must also be scalable so it can grow as demand increases. In addition, the development process must address realistic constraints such as budget, timeline, technical resources, and operational needs.</a:t>
-            </a:r>
+            <a:pPr marL="0" marR="0" lvl="0" indent="0" algn="l" defTabSz="914400" rtl="0" eaLnBrk="1" fontAlgn="auto" latinLnBrk="0" hangingPunct="1">
+              <a:lnSpc>
+                <a:spcPct val="100000"/>
+              </a:lnSpc>
+              <a:spcBef>
+                <a:spcPts val="0"/>
+              </a:spcBef>
+              <a:spcAft>
+                <a:spcPts val="0"/>
+              </a:spcAft>
+              <a:buClrTx/>
+              <a:buSzTx/>
+              <a:buFontTx/>
+              <a:buNone/>
+              <a:tabLst/>
+              <a:defRPr/>
+            </a:pPr>
+            <a:r>
+              <a:rPr lang="en-US" sz="1200" kern="1200" dirty="0">
+                <a:effectLst/>
+              </a:rPr>
+              <a:t>The primary goals of Byte Bazaar are to improve the online shopping experience, ensure secure transactions, and provide the business with effective tools for managing products and orders. The system must also be scalable so it can grow as demand increases. In addition, the development process must address realistic constraints such as budget, timeline, technical resources, and operational needs.</a:t>
+            </a:r>
+          </a:p>
+          <a:p>
+            <a:endParaRPr dirty="0"/>
           </a:p>
         </p:txBody>
       </p:sp>
@@ -1118,9 +1169,12 @@
           <a:lstStyle/>
           <a:p>
             <a:r>
-              <a:rPr dirty="0"/>
-              <a:t>The economic analysis examined whether Byte Bazaar would be financially worthwhile. Costs included development labor, software tools, infrastructure, hosting, and maintenance. Benefits included increased sales opportunities, reduced manual processing, better customer retention, and improved operational efficiency. From a business perspective, the project offers long-term value because the investment in a structured e-commerce platform can support both immediate functionality and future growth.</a:t>
-            </a:r>
+              <a:rPr lang="en-US" sz="1200" b="0" i="0" kern="1200" dirty="0">
+                <a:effectLst/>
+              </a:rPr>
+              <a:t>The economic analysis phase involved a thorough assessment of all costs associated with the project, including software development labor, hardware and infrastructure expenses, and ongoing maintenance. We also projected the benefits, such as increased revenue from online sales, improved operational efficiency by automating manual processes, and enhanced customer retention through better service. By comparing these costs and benefits, we established a positive return on investment, justifying the project’s continuation. Additionally, we evaluated risks such as market competition and technology changes to ensure informed decision-making.</a:t>
+            </a:r>
+            <a:endParaRPr dirty="0"/>
           </a:p>
         </p:txBody>
       </p:sp>
@@ -1196,9 +1250,12 @@
           <a:lstStyle/>
           <a:p>
             <a:r>
-              <a:rPr dirty="0"/>
-              <a:t>Leading the project team requires clear communication, organization, and accountability. Each team member should understand their responsibilities, project deadlines, and deliverables. Strong leadership helps ensure that development activities remain aligned with project goals. Collaboration and regular feedback are also essential, especially in an SDLC environment where planning, analysis, design, and implementation are interconnected.</a:t>
-            </a:r>
+              <a:rPr lang="en-US" sz="1200" b="0" i="0" kern="1200" dirty="0">
+                <a:effectLst/>
+              </a:rPr>
+              <a:t>Effective team leadership is critical to project success. For Byte Bazaar, roles were clearly defined to ensure accountability: developers focused on coding, testers on quality assurance, project managers on coordination, and business analysts on requirements gathering. Communication protocols such as daily stand-ups and weekly progress reports kept everyone aligned. Encouraging collaboration helped the team quickly resolve challenges. Setting realistic deadlines and tracking milestones ensured steady progress and timely delivery.</a:t>
+            </a:r>
+            <a:endParaRPr dirty="0"/>
           </a:p>
         </p:txBody>
       </p:sp>
@@ -1274,9 +1331,12 @@
           <a:lstStyle/>
           <a:p>
             <a:r>
-              <a:rPr dirty="0"/>
-              <a:t>The planning phase is one of the most important stages in the SDLC because it establishes the project foundation. During this phase, the scope of Byte Bazaar was defined, stakeholders were identified, and key requirements were gathered. Feasibility was assessed in terms of cost, technical capability, and scheduling. Risks were also identified early so they could be managed before they became major issues during development.</a:t>
-            </a:r>
+              <a:rPr lang="en-US" sz="1200" b="0" i="0" kern="1200" dirty="0">
+                <a:effectLst/>
+              </a:rPr>
+              <a:t>During planning, we clearly defined the scope of Byte Bazaar to avoid scope creep and set achievable objectives. Feasibility studies assessed whether the project was technically possible, operationally viable, and economically justified. Risks such as technology limitations and market shifts were identified early, with mitigation plans developed. A detailed schedule outlined key milestones, and resources were allocated to ensure the project stayed on track.</a:t>
+            </a:r>
+            <a:endParaRPr dirty="0"/>
           </a:p>
         </p:txBody>
       </p:sp>
@@ -1352,9 +1412,12 @@
           <a:lstStyle/>
           <a:p>
             <a:r>
-              <a:rPr dirty="0"/>
-              <a:t>The control aspect of the SDLC ensures that the project stays on track. This includes monitoring progress, managing changes, tracking deadlines, and controlling costs. For Byte Bazaar, control activities help maintain alignment between the original project goals and the work completed at each milestone. Effective control reduces the chance of scope creep, missed deadlines, and quality problems.</a:t>
-            </a:r>
+              <a:rPr lang="en-US" sz="1200" b="0" i="0" kern="1200" dirty="0">
+                <a:effectLst/>
+              </a:rPr>
+              <a:t>The Software Development Life Cycle, or SDLC, provides a structured approach to software development, consisting of six key phases. Planning defines the project scope and resources; analysis gathers detailed requirements; design creates system blueprints; implementation involves coding; testing verifies functionality; and maintenance supports ongoing improvements. Byte Bazaar uses an iterative approach, allowing flexibility to adapt to changes while emphasizing planning and control to manage risks effectively.</a:t>
+            </a:r>
+            <a:endParaRPr dirty="0"/>
           </a:p>
         </p:txBody>
       </p:sp>
@@ -1430,9 +1493,12 @@
           <a:lstStyle/>
           <a:p>
             <a:r>
-              <a:rPr dirty="0"/>
-              <a:t>The functional specifications define what Byte Bazaar must accomplish from the user and business perspective. These specifications include customer account creation, secure login, product browsing, shopping cart functions, checkout, payment handling, and order tracking. Administrative functions such as managing product listings, updating inventory, and processing orders are also part of the functional requirements. These specifications serve as a guide for ensuring the system meets user needs.</a:t>
-            </a:r>
+              <a:rPr lang="en-US" sz="1200" b="0" i="0" kern="1200" dirty="0">
+                <a:effectLst/>
+              </a:rPr>
+              <a:t>Functional specifications describe what Byte Bazaar must do from the user’s perspective. Key features include user registration and secure login, product search and browsing, shopping cart management, checkout with payment processing, and order tracking. For administrators, features include managing product listings, controlling inventory, and processing orders. Workflow diagrams help visualize user interactions, and acceptance criteria define how each function will be validated.</a:t>
+            </a:r>
+            <a:endParaRPr dirty="0"/>
           </a:p>
         </p:txBody>
       </p:sp>
@@ -1508,9 +1574,12 @@
           <a:lstStyle/>
           <a:p>
             <a:r>
-              <a:rPr dirty="0"/>
-              <a:t>Technical specifications explain how Byte Bazaar will be developed and implemented. These include the system architecture, database structure, backend processes, APIs, authentication controls, and hosting environment. Security is especially important in e-commerce, so encryption, secure login, and protected transactions are key elements. Technical specifications ensure the development team has a clear blueprint for building a system that is reliable, scalable, and secure.</a:t>
-            </a:r>
+              <a:rPr lang="en-US" sz="1200" b="0" i="0" kern="1200" dirty="0">
+                <a:effectLst/>
+              </a:rPr>
+              <a:t>Technical specifications detail how Byte Bazaar will be built. The system uses a client-server architecture with a web-based frontend accessible via browsers. The backend employs a relational database to store product, user, and order data. APIs integrate payment gateways and other third-party services. Security is paramount, with SSL encryption protecting data in transit, multi-factor authentication securing accounts, and data protection policies in place. Performance considerations include load balancing and caching to ensure the system scales efficiently under high traffic.</a:t>
+            </a:r>
+            <a:endParaRPr dirty="0"/>
           </a:p>
         </p:txBody>
       </p:sp>

</xml_diff>